<commit_message>
Update presentation palette to Tricentis colors (blue + orange)
Primary #01499B (Tricentis blue), accent #F36F21 (Tricentis orange).
Replaces prior navy/green/amber palette.

Co-Authored-By: Claude Sonnet 4.6 <noreply@anthropic.com>
</commit_message>
<xml_diff>
--- a/docs/presentations/guardrails-lunch-and-learn-2026-06-15.pptx
+++ b/docs/presentations/guardrails-lunch-and-learn-2026-06-15.pptx
@@ -1925,7 +1925,7 @@
     <p:bg>
       <p:bgPr>
         <a:solidFill>
-          <a:srgbClr val="1F3A5F"/>
+          <a:srgbClr val="01499B"/>
         </a:solidFill>
       </p:bgPr>
     </p:bg>
@@ -1960,7 +1960,7 @@
             </a:avLst>
           </a:prstGeom>
           <a:solidFill>
-            <a:srgbClr val="059669"/>
+            <a:srgbClr val="F36F21"/>
           </a:solidFill>
           <a:ln/>
         </p:spPr>
@@ -2083,7 +2083,7 @@
             <a:r>
               <a:rPr lang="en-US" sz="2200" dirty="0">
                 <a:solidFill>
-                  <a:srgbClr val="93C5FD"/>
+                  <a:srgbClr val="FBB98C"/>
                 </a:solidFill>
                 <a:latin typeface="Arial" pitchFamily="34" charset="0"/>
                 <a:ea typeface="Arial" pitchFamily="34" charset="-122"/>
@@ -2295,7 +2295,7 @@
             <a:avLst/>
           </a:prstGeom>
           <a:solidFill>
-            <a:srgbClr val="1F3A5F"/>
+            <a:srgbClr val="01499B"/>
           </a:solidFill>
           <a:ln/>
         </p:spPr>
@@ -2366,7 +2366,7 @@
             </a:avLst>
           </a:prstGeom>
           <a:solidFill>
-            <a:srgbClr val="1F3A5F"/>
+            <a:srgbClr val="01499B"/>
           </a:solidFill>
           <a:ln/>
         </p:spPr>
@@ -2447,7 +2447,7 @@
             <a:r>
               <a:rPr lang="en-US" sz="1600" dirty="0">
                 <a:solidFill>
-                  <a:srgbClr val="1F3A5F"/>
+                  <a:srgbClr val="01499B"/>
                 </a:solidFill>
                 <a:latin typeface="Arial" pitchFamily="34" charset="0"/>
                 <a:ea typeface="Arial" pitchFamily="34" charset="-122"/>
@@ -2701,7 +2701,7 @@
             <a:r>
               <a:rPr lang="en-US" sz="1100" b="1" dirty="0">
                 <a:solidFill>
-                  <a:srgbClr val="059669"/>
+                  <a:srgbClr val="F36F21"/>
                 </a:solidFill>
                 <a:latin typeface="Arial" pitchFamily="34" charset="0"/>
                 <a:ea typeface="Arial" pitchFamily="34" charset="-122"/>
@@ -2730,11 +2730,11 @@
             </a:avLst>
           </a:prstGeom>
           <a:solidFill>
-            <a:srgbClr val="ECFDF5"/>
+            <a:srgbClr val="FEF0E6"/>
           </a:solidFill>
           <a:ln w="19050">
             <a:solidFill>
-              <a:srgbClr val="059669"/>
+              <a:srgbClr val="F36F21"/>
             </a:solidFill>
           </a:ln>
         </p:spPr>
@@ -2776,7 +2776,7 @@
             <a:r>
               <a:rPr lang="en-US" sz="1100" b="1" dirty="0">
                 <a:solidFill>
-                  <a:srgbClr val="065F46"/>
+                  <a:srgbClr val="7C2D10"/>
                 </a:solidFill>
                 <a:latin typeface="Arial" pitchFamily="34" charset="0"/>
                 <a:ea typeface="Arial" pitchFamily="34" charset="-122"/>
@@ -2805,11 +2805,11 @@
             </a:avLst>
           </a:prstGeom>
           <a:solidFill>
-            <a:srgbClr val="ECFDF5"/>
+            <a:srgbClr val="FEF0E6"/>
           </a:solidFill>
           <a:ln w="19050">
             <a:solidFill>
-              <a:srgbClr val="059669"/>
+              <a:srgbClr val="F36F21"/>
             </a:solidFill>
           </a:ln>
         </p:spPr>
@@ -2851,7 +2851,7 @@
             <a:r>
               <a:rPr lang="en-US" sz="1100" b="1" dirty="0">
                 <a:solidFill>
-                  <a:srgbClr val="065F46"/>
+                  <a:srgbClr val="7C2D10"/>
                 </a:solidFill>
                 <a:latin typeface="Arial" pitchFamily="34" charset="0"/>
                 <a:ea typeface="Arial" pitchFamily="34" charset="-122"/>
@@ -2910,7 +2910,7 @@
           <a:noFill/>
           <a:ln w="47625">
             <a:solidFill>
-              <a:srgbClr val="1F3A5F"/>
+              <a:srgbClr val="01499B"/>
             </a:solidFill>
             <a:prstDash val="solid"/>
           </a:ln>
@@ -2946,7 +2946,7 @@
             <a:r>
               <a:rPr lang="en-US" sz="1300" b="1" dirty="0">
                 <a:solidFill>
-                  <a:srgbClr val="1F3A5F"/>
+                  <a:srgbClr val="01499B"/>
                 </a:solidFill>
                 <a:latin typeface="Arial" pitchFamily="34" charset="0"/>
                 <a:ea typeface="Arial" pitchFamily="34" charset="-122"/>
@@ -3069,7 +3069,7 @@
             <a:avLst/>
           </a:prstGeom>
           <a:solidFill>
-            <a:srgbClr val="1F3A5F"/>
+            <a:srgbClr val="01499B"/>
           </a:solidFill>
           <a:ln/>
         </p:spPr>
@@ -3161,7 +3161,7 @@
             <a:avLst/>
           </a:prstGeom>
           <a:solidFill>
-            <a:srgbClr val="1F3A5F"/>
+            <a:srgbClr val="01499B"/>
           </a:solidFill>
           <a:ln/>
         </p:spPr>
@@ -3253,7 +3253,7 @@
             <a:avLst/>
           </a:prstGeom>
           <a:solidFill>
-            <a:srgbClr val="ECFDF5"/>
+            <a:srgbClr val="FEF0E6"/>
           </a:solidFill>
           <a:ln/>
         </p:spPr>
@@ -3318,7 +3318,7 @@
             <a:r>
               <a:rPr lang="en-US" sz="1600" b="1" dirty="0">
                 <a:solidFill>
-                  <a:srgbClr val="059669"/>
+                  <a:srgbClr val="F36F21"/>
                 </a:solidFill>
                 <a:latin typeface="Arial" pitchFamily="34" charset="0"/>
                 <a:ea typeface="Arial" pitchFamily="34" charset="-122"/>
@@ -3758,7 +3758,7 @@
     <p:bg>
       <p:bgPr>
         <a:solidFill>
-          <a:srgbClr val="1F3A5F"/>
+          <a:srgbClr val="01499B"/>
         </a:solidFill>
       </p:bgPr>
     </p:bg>
@@ -3845,7 +3845,7 @@
             <a:r>
               <a:rPr lang="en-US" sz="2000" dirty="0">
                 <a:solidFill>
-                  <a:srgbClr val="93C5FD"/>
+                  <a:srgbClr val="FBB98C"/>
                 </a:solidFill>
                 <a:latin typeface="Arial" pitchFamily="34" charset="0"/>
                 <a:ea typeface="Arial" pitchFamily="34" charset="-122"/>
@@ -3904,7 +3904,7 @@
             <a:avLst/>
           </a:prstGeom>
           <a:solidFill>
-            <a:srgbClr val="1F3A5F"/>
+            <a:srgbClr val="01499B"/>
           </a:solidFill>
           <a:ln/>
         </p:spPr>
@@ -4368,7 +4368,7 @@
             <a:r>
               <a:rPr lang="en-US" sz="1200" b="1" dirty="0">
                 <a:solidFill>
-                  <a:srgbClr val="1F3A5F"/>
+                  <a:srgbClr val="01499B"/>
                 </a:solidFill>
                 <a:latin typeface="Arial" pitchFamily="34" charset="0"/>
                 <a:ea typeface="Arial" pitchFamily="34" charset="-122"/>
@@ -4485,7 +4485,7 @@
             <a:r>
               <a:rPr lang="en-US" sz="1200" b="1" dirty="0">
                 <a:solidFill>
-                  <a:srgbClr val="1F3A5F"/>
+                  <a:srgbClr val="01499B"/>
                 </a:solidFill>
                 <a:latin typeface="Arial" pitchFamily="34" charset="0"/>
                 <a:ea typeface="Arial" pitchFamily="34" charset="-122"/>
@@ -4602,7 +4602,7 @@
             <a:r>
               <a:rPr lang="en-US" sz="1200" b="1" dirty="0">
                 <a:solidFill>
-                  <a:srgbClr val="1F3A5F"/>
+                  <a:srgbClr val="01499B"/>
                 </a:solidFill>
                 <a:latin typeface="Arial" pitchFamily="34" charset="0"/>
                 <a:ea typeface="Arial" pitchFamily="34" charset="-122"/>
@@ -4719,7 +4719,7 @@
             <a:r>
               <a:rPr lang="en-US" sz="1200" b="1" dirty="0">
                 <a:solidFill>
-                  <a:srgbClr val="059669"/>
+                  <a:srgbClr val="F36F21"/>
                 </a:solidFill>
                 <a:latin typeface="Arial" pitchFamily="34" charset="0"/>
                 <a:ea typeface="Arial" pitchFamily="34" charset="-122"/>
@@ -4817,7 +4817,7 @@
             <a:avLst/>
           </a:prstGeom>
           <a:solidFill>
-            <a:srgbClr val="1F3A5F"/>
+            <a:srgbClr val="01499B"/>
           </a:solidFill>
           <a:ln/>
         </p:spPr>
@@ -4920,7 +4920,7 @@
           <a:noFill/>
           <a:ln w="47625">
             <a:solidFill>
-              <a:srgbClr val="1F3A5F"/>
+              <a:srgbClr val="01499B"/>
             </a:solidFill>
             <a:prstDash val="solid"/>
           </a:ln>
@@ -4956,7 +4956,7 @@
             <a:r>
               <a:rPr lang="en-US" sz="2200" b="1" dirty="0">
                 <a:solidFill>
-                  <a:srgbClr val="1F3A5F"/>
+                  <a:srgbClr val="01499B"/>
                 </a:solidFill>
                 <a:latin typeface="Arial" pitchFamily="34" charset="0"/>
                 <a:ea typeface="Arial" pitchFamily="34" charset="-122"/>
@@ -4998,7 +4998,7 @@
             <a:r>
               <a:rPr lang="en-US" sz="1300" b="1" dirty="0">
                 <a:solidFill>
-                  <a:srgbClr val="1F3A5F"/>
+                  <a:srgbClr val="01499B"/>
                 </a:solidFill>
                 <a:latin typeface="Arial" pitchFamily="34" charset="0"/>
                 <a:ea typeface="Arial" pitchFamily="34" charset="-122"/>
@@ -5066,7 +5066,7 @@
             </a:avLst>
           </a:prstGeom>
           <a:solidFill>
-            <a:srgbClr val="ECFDF5"/>
+            <a:srgbClr val="FEF0E6"/>
           </a:solidFill>
           <a:ln/>
         </p:spPr>
@@ -5098,7 +5098,7 @@
           <a:noFill/>
           <a:ln w="47625">
             <a:solidFill>
-              <a:srgbClr val="059669"/>
+              <a:srgbClr val="F36F21"/>
             </a:solidFill>
             <a:prstDash val="solid"/>
           </a:ln>
@@ -5134,7 +5134,7 @@
             <a:r>
               <a:rPr lang="en-US" sz="2200" b="1" dirty="0">
                 <a:solidFill>
-                  <a:srgbClr val="059669"/>
+                  <a:srgbClr val="F36F21"/>
                 </a:solidFill>
                 <a:latin typeface="Arial" pitchFamily="34" charset="0"/>
                 <a:ea typeface="Arial" pitchFamily="34" charset="-122"/>
@@ -5176,7 +5176,7 @@
             <a:r>
               <a:rPr lang="en-US" sz="1300" b="1" dirty="0">
                 <a:solidFill>
-                  <a:srgbClr val="065F46"/>
+                  <a:srgbClr val="7C2D10"/>
                 </a:solidFill>
                 <a:latin typeface="Arial" pitchFamily="34" charset="0"/>
                 <a:ea typeface="Arial" pitchFamily="34" charset="-122"/>
@@ -5846,7 +5846,7 @@
             <a:r>
               <a:rPr lang="en-US" sz="1200" dirty="0">
                 <a:solidFill>
-                  <a:srgbClr val="86EFAC"/>
+                  <a:srgbClr val="FBB98C"/>
                 </a:solidFill>
                 <a:latin typeface="Courier New" pitchFamily="34" charset="0"/>
                 <a:ea typeface="Courier New" pitchFamily="34" charset="-122"/>
@@ -5905,7 +5905,7 @@
             <a:avLst/>
           </a:prstGeom>
           <a:solidFill>
-            <a:srgbClr val="1F3A5F"/>
+            <a:srgbClr val="01499B"/>
           </a:solidFill>
           <a:ln/>
         </p:spPr>
@@ -5976,11 +5976,11 @@
             </a:avLst>
           </a:prstGeom>
           <a:solidFill>
-            <a:srgbClr val="ECFDF5"/>
+            <a:srgbClr val="FEF0E6"/>
           </a:solidFill>
           <a:ln w="19050">
             <a:solidFill>
-              <a:srgbClr val="059669"/>
+              <a:srgbClr val="F36F21"/>
             </a:solidFill>
           </a:ln>
         </p:spPr>
@@ -6025,7 +6025,7 @@
             <a:r>
               <a:rPr lang="en-US" sz="1300" b="1" dirty="0">
                 <a:solidFill>
-                  <a:srgbClr val="059669"/>
+                  <a:srgbClr val="F36F21"/>
                 </a:solidFill>
                 <a:latin typeface="Arial" pitchFamily="34" charset="0"/>
                 <a:ea typeface="Arial" pitchFamily="34" charset="-122"/>
@@ -6054,7 +6054,7 @@
             </a:avLst>
           </a:prstGeom>
           <a:solidFill>
-            <a:srgbClr val="059669"/>
+            <a:srgbClr val="F36F21"/>
           </a:solidFill>
           <a:ln/>
         </p:spPr>
@@ -6438,7 +6438,7 @@
           <a:noFill/>
           <a:ln w="57150">
             <a:solidFill>
-              <a:srgbClr val="1F3A5F"/>
+              <a:srgbClr val="01499B"/>
             </a:solidFill>
             <a:prstDash val="solid"/>
           </a:ln>
@@ -6471,7 +6471,7 @@
             <a:r>
               <a:rPr lang="en-US" sz="1400" b="1" dirty="0">
                 <a:solidFill>
-                  <a:srgbClr val="1F3A5F"/>
+                  <a:srgbClr val="01499B"/>
                 </a:solidFill>
                 <a:latin typeface="Arial" pitchFamily="34" charset="0"/>
                 <a:ea typeface="Arial" pitchFamily="34" charset="-122"/>
@@ -6530,7 +6530,7 @@
             <a:avLst/>
           </a:prstGeom>
           <a:solidFill>
-            <a:srgbClr val="1F3A5F"/>
+            <a:srgbClr val="01499B"/>
           </a:solidFill>
           <a:ln/>
         </p:spPr>
@@ -6633,7 +6633,7 @@
             </a:avLst>
           </a:prstGeom>
           <a:solidFill>
-            <a:srgbClr val="1F3A5F"/>
+            <a:srgbClr val="01499B"/>
           </a:solidFill>
           <a:ln/>
         </p:spPr>
@@ -6857,7 +6857,7 @@
             </a:avLst>
           </a:prstGeom>
           <a:solidFill>
-            <a:srgbClr val="1F3A5F"/>
+            <a:srgbClr val="01499B"/>
           </a:solidFill>
           <a:ln/>
         </p:spPr>
@@ -7012,7 +7012,7 @@
             <a:r>
               <a:rPr lang="en-US" sz="1300" b="1" dirty="0">
                 <a:solidFill>
-                  <a:srgbClr val="1F3A5F"/>
+                  <a:srgbClr val="01499B"/>
                 </a:solidFill>
                 <a:latin typeface="Arial" pitchFamily="34" charset="0"/>
                 <a:ea typeface="Arial" pitchFamily="34" charset="-122"/>
@@ -7125,7 +7125,7 @@
             <a:r>
               <a:rPr lang="en-US" sz="1300" b="1" dirty="0">
                 <a:solidFill>
-                  <a:srgbClr val="1F3A5F"/>
+                  <a:srgbClr val="01499B"/>
                 </a:solidFill>
                 <a:latin typeface="Arial" pitchFamily="34" charset="0"/>
                 <a:ea typeface="Arial" pitchFamily="34" charset="-122"/>
@@ -7238,7 +7238,7 @@
             <a:r>
               <a:rPr lang="en-US" sz="1300" b="1" dirty="0">
                 <a:solidFill>
-                  <a:srgbClr val="1F3A5F"/>
+                  <a:srgbClr val="01499B"/>
                 </a:solidFill>
                 <a:latin typeface="Arial" pitchFamily="34" charset="0"/>
                 <a:ea typeface="Arial" pitchFamily="34" charset="-122"/>
@@ -7351,7 +7351,7 @@
             <a:r>
               <a:rPr lang="en-US" sz="1300" b="1" dirty="0">
                 <a:solidFill>
-                  <a:srgbClr val="1F3A5F"/>
+                  <a:srgbClr val="01499B"/>
                 </a:solidFill>
                 <a:latin typeface="Arial" pitchFamily="34" charset="0"/>
                 <a:ea typeface="Arial" pitchFamily="34" charset="-122"/>
@@ -7449,7 +7449,7 @@
           <a:noFill/>
           <a:ln w="57150">
             <a:solidFill>
-              <a:srgbClr val="1F3A5F"/>
+              <a:srgbClr val="01499B"/>
             </a:solidFill>
             <a:prstDash val="solid"/>
           </a:ln>
@@ -7555,7 +7555,7 @@
             <a:avLst/>
           </a:prstGeom>
           <a:solidFill>
-            <a:srgbClr val="1F3A5F"/>
+            <a:srgbClr val="01499B"/>
           </a:solidFill>
           <a:ln/>
         </p:spPr>
@@ -7630,7 +7630,7 @@
           </a:solidFill>
           <a:ln w="19050">
             <a:solidFill>
-              <a:srgbClr val="1F3A5F"/>
+              <a:srgbClr val="01499B"/>
             </a:solidFill>
           </a:ln>
         </p:spPr>
@@ -7672,7 +7672,7 @@
             <a:r>
               <a:rPr lang="en-US" sz="1500" dirty="0">
                 <a:solidFill>
-                  <a:srgbClr val="1F3A5F"/>
+                  <a:srgbClr val="01499B"/>
                 </a:solidFill>
                 <a:latin typeface="Arial" pitchFamily="34" charset="0"/>
                 <a:ea typeface="Arial" pitchFamily="34" charset="-122"/>
@@ -7686,7 +7686,7 @@
             <a:r>
               <a:rPr lang="en-US" sz="1500" b="1" i="1" dirty="0">
                 <a:solidFill>
-                  <a:srgbClr val="1F3A5F"/>
+                  <a:srgbClr val="01499B"/>
                 </a:solidFill>
                 <a:latin typeface="Arial" pitchFamily="34" charset="0"/>
                 <a:ea typeface="Arial" pitchFamily="34" charset="-122"/>
@@ -7700,7 +7700,7 @@
             <a:r>
               <a:rPr lang="en-US" sz="1500" dirty="0">
                 <a:solidFill>
-                  <a:srgbClr val="1F3A5F"/>
+                  <a:srgbClr val="01499B"/>
                 </a:solidFill>
                 <a:latin typeface="Arial" pitchFamily="34" charset="0"/>
                 <a:ea typeface="Arial" pitchFamily="34" charset="-122"/>
@@ -7729,7 +7729,7 @@
             </a:avLst>
           </a:prstGeom>
           <a:solidFill>
-            <a:srgbClr val="1F3A5F"/>
+            <a:srgbClr val="01499B"/>
           </a:solidFill>
           <a:ln/>
         </p:spPr>
@@ -7813,7 +7813,7 @@
             <a:r>
               <a:rPr lang="en-US" sz="1300" b="1" dirty="0">
                 <a:solidFill>
-                  <a:srgbClr val="1F3A5F"/>
+                  <a:srgbClr val="01499B"/>
                 </a:solidFill>
                 <a:latin typeface="Arial" pitchFamily="34" charset="0"/>
                 <a:ea typeface="Arial" pitchFamily="34" charset="-122"/>
@@ -7881,7 +7881,7 @@
             </a:avLst>
           </a:prstGeom>
           <a:solidFill>
-            <a:srgbClr val="1F3A5F"/>
+            <a:srgbClr val="01499B"/>
           </a:solidFill>
           <a:ln/>
         </p:spPr>
@@ -7965,7 +7965,7 @@
             <a:r>
               <a:rPr lang="en-US" sz="1300" b="1" dirty="0">
                 <a:solidFill>
-                  <a:srgbClr val="1F3A5F"/>
+                  <a:srgbClr val="01499B"/>
                 </a:solidFill>
                 <a:latin typeface="Arial" pitchFamily="34" charset="0"/>
                 <a:ea typeface="Arial" pitchFamily="34" charset="-122"/>
@@ -8033,7 +8033,7 @@
             </a:avLst>
           </a:prstGeom>
           <a:solidFill>
-            <a:srgbClr val="1F3A5F"/>
+            <a:srgbClr val="01499B"/>
           </a:solidFill>
           <a:ln/>
         </p:spPr>
@@ -8117,7 +8117,7 @@
             <a:r>
               <a:rPr lang="en-US" sz="1300" b="1" dirty="0">
                 <a:solidFill>
-                  <a:srgbClr val="1F3A5F"/>
+                  <a:srgbClr val="01499B"/>
                 </a:solidFill>
                 <a:latin typeface="Arial" pitchFamily="34" charset="0"/>
                 <a:ea typeface="Arial" pitchFamily="34" charset="-122"/>
@@ -8596,7 +8596,7 @@
             <a:avLst/>
           </a:prstGeom>
           <a:solidFill>
-            <a:srgbClr val="1F3A5F"/>
+            <a:srgbClr val="01499B"/>
           </a:solidFill>
           <a:ln/>
         </p:spPr>
@@ -8671,7 +8671,7 @@
           </a:solidFill>
           <a:ln w="19050">
             <a:solidFill>
-              <a:srgbClr val="1F3A5F"/>
+              <a:srgbClr val="01499B"/>
             </a:solidFill>
           </a:ln>
         </p:spPr>
@@ -8716,7 +8716,7 @@
             <a:r>
               <a:rPr lang="en-US" sz="1800" b="1" dirty="0">
                 <a:solidFill>
-                  <a:srgbClr val="059669"/>
+                  <a:srgbClr val="F36F21"/>
                 </a:solidFill>
                 <a:latin typeface="Arial" pitchFamily="34" charset="0"/>
                 <a:ea typeface="Arial" pitchFamily="34" charset="-122"/>
@@ -8758,7 +8758,7 @@
             <a:r>
               <a:rPr lang="en-US" sz="1200" b="1" dirty="0">
                 <a:solidFill>
-                  <a:srgbClr val="1F3A5F"/>
+                  <a:srgbClr val="01499B"/>
                 </a:solidFill>
                 <a:latin typeface="Arial" pitchFamily="34" charset="0"/>
                 <a:ea typeface="Arial" pitchFamily="34" charset="-122"/>
@@ -8836,7 +8836,7 @@
             <a:r>
               <a:rPr lang="en-US" sz="1800" dirty="0">
                 <a:solidFill>
-                  <a:srgbClr val="1F3A5F"/>
+                  <a:srgbClr val="01499B"/>
                 </a:solidFill>
                 <a:latin typeface="Arial" pitchFamily="34" charset="0"/>
                 <a:ea typeface="Arial" pitchFamily="34" charset="-122"/>
@@ -8869,7 +8869,7 @@
           </a:solidFill>
           <a:ln w="19050">
             <a:solidFill>
-              <a:srgbClr val="1F3A5F"/>
+              <a:srgbClr val="01499B"/>
             </a:solidFill>
           </a:ln>
         </p:spPr>
@@ -8914,7 +8914,7 @@
             <a:r>
               <a:rPr lang="en-US" sz="1800" b="1" dirty="0">
                 <a:solidFill>
-                  <a:srgbClr val="059669"/>
+                  <a:srgbClr val="F36F21"/>
                 </a:solidFill>
                 <a:latin typeface="Arial" pitchFamily="34" charset="0"/>
                 <a:ea typeface="Arial" pitchFamily="34" charset="-122"/>
@@ -8956,7 +8956,7 @@
             <a:r>
               <a:rPr lang="en-US" sz="1200" b="1" dirty="0">
                 <a:solidFill>
-                  <a:srgbClr val="1F3A5F"/>
+                  <a:srgbClr val="01499B"/>
                 </a:solidFill>
                 <a:latin typeface="Arial" pitchFamily="34" charset="0"/>
                 <a:ea typeface="Arial" pitchFamily="34" charset="-122"/>
@@ -9034,7 +9034,7 @@
             <a:r>
               <a:rPr lang="en-US" sz="1800" dirty="0">
                 <a:solidFill>
-                  <a:srgbClr val="1F3A5F"/>
+                  <a:srgbClr val="01499B"/>
                 </a:solidFill>
                 <a:latin typeface="Arial" pitchFamily="34" charset="0"/>
                 <a:ea typeface="Arial" pitchFamily="34" charset="-122"/>
@@ -9067,7 +9067,7 @@
           </a:solidFill>
           <a:ln w="19050">
             <a:solidFill>
-              <a:srgbClr val="1F3A5F"/>
+              <a:srgbClr val="01499B"/>
             </a:solidFill>
           </a:ln>
         </p:spPr>
@@ -9112,7 +9112,7 @@
             <a:r>
               <a:rPr lang="en-US" sz="1800" b="1" dirty="0">
                 <a:solidFill>
-                  <a:srgbClr val="059669"/>
+                  <a:srgbClr val="F36F21"/>
                 </a:solidFill>
                 <a:latin typeface="Arial" pitchFamily="34" charset="0"/>
                 <a:ea typeface="Arial" pitchFamily="34" charset="-122"/>
@@ -9154,7 +9154,7 @@
             <a:r>
               <a:rPr lang="en-US" sz="1200" b="1" dirty="0">
                 <a:solidFill>
-                  <a:srgbClr val="1F3A5F"/>
+                  <a:srgbClr val="01499B"/>
                 </a:solidFill>
                 <a:latin typeface="Arial" pitchFamily="34" charset="0"/>
                 <a:ea typeface="Arial" pitchFamily="34" charset="-122"/>
@@ -9232,7 +9232,7 @@
             <a:r>
               <a:rPr lang="en-US" sz="1800" dirty="0">
                 <a:solidFill>
-                  <a:srgbClr val="1F3A5F"/>
+                  <a:srgbClr val="01499B"/>
                 </a:solidFill>
                 <a:latin typeface="Arial" pitchFamily="34" charset="0"/>
                 <a:ea typeface="Arial" pitchFamily="34" charset="-122"/>
@@ -9265,7 +9265,7 @@
           </a:solidFill>
           <a:ln w="19050">
             <a:solidFill>
-              <a:srgbClr val="1F3A5F"/>
+              <a:srgbClr val="01499B"/>
             </a:solidFill>
           </a:ln>
         </p:spPr>
@@ -9310,7 +9310,7 @@
             <a:r>
               <a:rPr lang="en-US" sz="1800" b="1" dirty="0">
                 <a:solidFill>
-                  <a:srgbClr val="059669"/>
+                  <a:srgbClr val="F36F21"/>
                 </a:solidFill>
                 <a:latin typeface="Arial" pitchFamily="34" charset="0"/>
                 <a:ea typeface="Arial" pitchFamily="34" charset="-122"/>
@@ -9352,7 +9352,7 @@
             <a:r>
               <a:rPr lang="en-US" sz="1200" b="1" dirty="0">
                 <a:solidFill>
-                  <a:srgbClr val="1F3A5F"/>
+                  <a:srgbClr val="01499B"/>
                 </a:solidFill>
                 <a:latin typeface="Arial" pitchFamily="34" charset="0"/>
                 <a:ea typeface="Arial" pitchFamily="34" charset="-122"/>
@@ -9475,7 +9475,7 @@
             <a:avLst/>
           </a:prstGeom>
           <a:solidFill>
-            <a:srgbClr val="1F3A5F"/>
+            <a:srgbClr val="01499B"/>
           </a:solidFill>
           <a:ln/>
         </p:spPr>
@@ -9567,7 +9567,7 @@
             <a:avLst/>
           </a:prstGeom>
           <a:solidFill>
-            <a:srgbClr val="1F3A5F"/>
+            <a:srgbClr val="01499B"/>
           </a:solidFill>
           <a:ln/>
         </p:spPr>
@@ -9659,7 +9659,7 @@
             <a:avLst/>
           </a:prstGeom>
           <a:solidFill>
-            <a:srgbClr val="1F3A5F"/>
+            <a:srgbClr val="01499B"/>
           </a:solidFill>
           <a:ln/>
         </p:spPr>
@@ -9816,7 +9816,7 @@
             <a:r>
               <a:rPr lang="en-US" sz="1200" b="1" dirty="0">
                 <a:solidFill>
-                  <a:srgbClr val="1F3A5F"/>
+                  <a:srgbClr val="01499B"/>
                 </a:solidFill>
                 <a:latin typeface="Arial" pitchFamily="34" charset="0"/>
                 <a:ea typeface="Arial" pitchFamily="34" charset="-122"/>
@@ -10092,7 +10092,7 @@
             <a:r>
               <a:rPr lang="en-US" sz="1200" b="1" dirty="0">
                 <a:solidFill>
-                  <a:srgbClr val="1F3A5F"/>
+                  <a:srgbClr val="01499B"/>
                 </a:solidFill>
                 <a:latin typeface="Arial" pitchFamily="34" charset="0"/>
                 <a:ea typeface="Arial" pitchFamily="34" charset="-122"/>
@@ -10368,7 +10368,7 @@
             <a:r>
               <a:rPr lang="en-US" sz="1200" b="1" dirty="0">
                 <a:solidFill>
-                  <a:srgbClr val="1F3A5F"/>
+                  <a:srgbClr val="01499B"/>
                 </a:solidFill>
                 <a:latin typeface="Arial" pitchFamily="34" charset="0"/>
                 <a:ea typeface="Arial" pitchFamily="34" charset="-122"/>
@@ -10621,7 +10621,7 @@
             <a:r>
               <a:rPr lang="en-US" sz="1200" b="1" dirty="0">
                 <a:solidFill>
-                  <a:srgbClr val="1F3A5F"/>
+                  <a:srgbClr val="01499B"/>
                 </a:solidFill>
                 <a:latin typeface="Arial" pitchFamily="34" charset="0"/>
                 <a:ea typeface="Arial" pitchFamily="34" charset="-122"/>
@@ -10841,7 +10841,7 @@
             <a:avLst/>
           </a:prstGeom>
           <a:solidFill>
-            <a:srgbClr val="1F3A5F"/>
+            <a:srgbClr val="01499B"/>
           </a:solidFill>
           <a:ln/>
         </p:spPr>
@@ -11377,7 +11377,7 @@
             <a:r>
               <a:rPr lang="en-US" sz="1000" dirty="0">
                 <a:solidFill>
-                  <a:srgbClr val="86EFAC"/>
+                  <a:srgbClr val="FBB98C"/>
                 </a:solidFill>
                 <a:latin typeface="Courier New" pitchFamily="34" charset="0"/>
                 <a:ea typeface="Courier New" pitchFamily="34" charset="-122"/>
@@ -11419,7 +11419,7 @@
             <a:r>
               <a:rPr lang="en-US" sz="1000" dirty="0">
                 <a:solidFill>
-                  <a:srgbClr val="86EFAC"/>
+                  <a:srgbClr val="FBB98C"/>
                 </a:solidFill>
                 <a:latin typeface="Courier New" pitchFamily="34" charset="0"/>
                 <a:ea typeface="Courier New" pitchFamily="34" charset="-122"/>
@@ -11587,7 +11587,7 @@
             <a:r>
               <a:rPr lang="en-US" sz="1000" dirty="0">
                 <a:solidFill>
-                  <a:srgbClr val="86EFAC"/>
+                  <a:srgbClr val="FBB98C"/>
                 </a:solidFill>
                 <a:latin typeface="Courier New" pitchFamily="34" charset="0"/>
                 <a:ea typeface="Courier New" pitchFamily="34" charset="-122"/>
@@ -11629,7 +11629,7 @@
             <a:r>
               <a:rPr lang="en-US" sz="1000" dirty="0">
                 <a:solidFill>
-                  <a:srgbClr val="86EFAC"/>
+                  <a:srgbClr val="FBB98C"/>
                 </a:solidFill>
                 <a:latin typeface="Courier New" pitchFamily="34" charset="0"/>
                 <a:ea typeface="Courier New" pitchFamily="34" charset="-122"/>
@@ -11688,7 +11688,7 @@
           <a:noFill/>
           <a:ln w="47625">
             <a:solidFill>
-              <a:srgbClr val="1F3A5F"/>
+              <a:srgbClr val="01499B"/>
             </a:solidFill>
             <a:prstDash val="solid"/>
           </a:ln>
@@ -11724,7 +11724,7 @@
             <a:r>
               <a:rPr lang="en-US" sz="1200" b="1" dirty="0">
                 <a:solidFill>
-                  <a:srgbClr val="1F3A5F"/>
+                  <a:srgbClr val="01499B"/>
                 </a:solidFill>
                 <a:latin typeface="Arial" pitchFamily="34" charset="0"/>
                 <a:ea typeface="Arial" pitchFamily="34" charset="-122"/>
@@ -11822,7 +11822,7 @@
           <a:noFill/>
           <a:ln w="47625">
             <a:solidFill>
-              <a:srgbClr val="1F3A5F"/>
+              <a:srgbClr val="01499B"/>
             </a:solidFill>
             <a:prstDash val="solid"/>
           </a:ln>
@@ -11858,7 +11858,7 @@
             <a:r>
               <a:rPr lang="en-US" sz="1200" b="1" dirty="0">
                 <a:solidFill>
-                  <a:srgbClr val="1F3A5F"/>
+                  <a:srgbClr val="01499B"/>
                 </a:solidFill>
                 <a:latin typeface="Arial" pitchFamily="34" charset="0"/>
                 <a:ea typeface="Arial" pitchFamily="34" charset="-122"/>
@@ -11956,7 +11956,7 @@
           <a:noFill/>
           <a:ln w="47625">
             <a:solidFill>
-              <a:srgbClr val="059669"/>
+              <a:srgbClr val="F36F21"/>
             </a:solidFill>
             <a:prstDash val="solid"/>
           </a:ln>
@@ -11992,7 +11992,7 @@
             <a:r>
               <a:rPr lang="en-US" sz="1200" b="1" dirty="0">
                 <a:solidFill>
-                  <a:srgbClr val="059669"/>
+                  <a:srgbClr val="F36F21"/>
                 </a:solidFill>
                 <a:latin typeface="Arial" pitchFamily="34" charset="0"/>
                 <a:ea typeface="Arial" pitchFamily="34" charset="-122"/>
@@ -12090,7 +12090,7 @@
           <a:noFill/>
           <a:ln w="47625">
             <a:solidFill>
-              <a:srgbClr val="1F3A5F"/>
+              <a:srgbClr val="01499B"/>
             </a:solidFill>
             <a:prstDash val="solid"/>
           </a:ln>
@@ -12126,7 +12126,7 @@
             <a:r>
               <a:rPr lang="en-US" sz="1200" b="1" dirty="0">
                 <a:solidFill>
-                  <a:srgbClr val="1F3A5F"/>
+                  <a:srgbClr val="01499B"/>
                 </a:solidFill>
                 <a:latin typeface="Arial" pitchFamily="34" charset="0"/>
                 <a:ea typeface="Arial" pitchFamily="34" charset="-122"/>
@@ -12224,7 +12224,7 @@
             <a:avLst/>
           </a:prstGeom>
           <a:solidFill>
-            <a:srgbClr val="1F3A5F"/>
+            <a:srgbClr val="01499B"/>
           </a:solidFill>
           <a:ln/>
         </p:spPr>
@@ -12295,11 +12295,11 @@
             </a:avLst>
           </a:prstGeom>
           <a:solidFill>
-            <a:srgbClr val="ECFDF5"/>
+            <a:srgbClr val="FEF0E6"/>
           </a:solidFill>
           <a:ln w="19050">
             <a:solidFill>
-              <a:srgbClr val="059669"/>
+              <a:srgbClr val="F36F21"/>
             </a:solidFill>
           </a:ln>
         </p:spPr>
@@ -12344,7 +12344,7 @@
             <a:r>
               <a:rPr lang="en-US" sz="1600" b="1" dirty="0">
                 <a:solidFill>
-                  <a:srgbClr val="065F46"/>
+                  <a:srgbClr val="7C2D10"/>
                 </a:solidFill>
                 <a:latin typeface="Arial" pitchFamily="34" charset="0"/>
                 <a:ea typeface="Arial" pitchFamily="34" charset="-122"/>
@@ -12383,7 +12383,7 @@
             <a:r>
               <a:rPr lang="en-US" sz="1300" dirty="0">
                 <a:solidFill>
-                  <a:srgbClr val="047857"/>
+                  <a:srgbClr val="C45C15"/>
                 </a:solidFill>
                 <a:latin typeface="Arial" pitchFamily="34" charset="0"/>
                 <a:ea typeface="Arial" pitchFamily="34" charset="-122"/>
@@ -12467,7 +12467,7 @@
             <a:avLst/>
           </a:prstGeom>
           <a:solidFill>
-            <a:srgbClr val="1F3A5F"/>
+            <a:srgbClr val="01499B"/>
           </a:solidFill>
           <a:ln/>
         </p:spPr>
@@ -12559,7 +12559,7 @@
             <a:avLst/>
           </a:prstGeom>
           <a:solidFill>
-            <a:srgbClr val="1F3A5F"/>
+            <a:srgbClr val="01499B"/>
           </a:solidFill>
           <a:ln/>
         </p:spPr>
@@ -12651,7 +12651,7 @@
             <a:avLst/>
           </a:prstGeom>
           <a:solidFill>
-            <a:srgbClr val="1F3A5F"/>
+            <a:srgbClr val="01499B"/>
           </a:solidFill>
           <a:ln/>
         </p:spPr>
@@ -12969,7 +12969,7 @@
             <a:r>
               <a:rPr lang="en-US" sz="1200" b="1" dirty="0">
                 <a:solidFill>
-                  <a:srgbClr val="059669"/>
+                  <a:srgbClr val="F36F21"/>
                 </a:solidFill>
                 <a:latin typeface="Arial" pitchFamily="34" charset="0"/>
                 <a:ea typeface="Arial" pitchFamily="34" charset="-122"/>
@@ -13245,7 +13245,7 @@
             <a:r>
               <a:rPr lang="en-US" sz="1200" b="1" dirty="0">
                 <a:solidFill>
-                  <a:srgbClr val="059669"/>
+                  <a:srgbClr val="F36F21"/>
                 </a:solidFill>
                 <a:latin typeface="Arial" pitchFamily="34" charset="0"/>
                 <a:ea typeface="Arial" pitchFamily="34" charset="-122"/>
@@ -14215,7 +14215,7 @@
             <a:avLst/>
           </a:prstGeom>
           <a:solidFill>
-            <a:srgbClr val="1F3A5F"/>
+            <a:srgbClr val="01499B"/>
           </a:solidFill>
           <a:ln/>
         </p:spPr>
@@ -14799,7 +14799,7 @@
           <a:noFill/>
           <a:ln w="47625">
             <a:solidFill>
-              <a:srgbClr val="1F3A5F"/>
+              <a:srgbClr val="01499B"/>
             </a:solidFill>
             <a:prstDash val="solid"/>
           </a:ln>
@@ -14835,7 +14835,7 @@
             <a:r>
               <a:rPr lang="en-US" sz="1200" b="1" dirty="0">
                 <a:solidFill>
-                  <a:srgbClr val="1F3A5F"/>
+                  <a:srgbClr val="01499B"/>
                 </a:solidFill>
                 <a:latin typeface="Arial" pitchFamily="34" charset="0"/>
                 <a:ea typeface="Arial" pitchFamily="34" charset="-122"/>
@@ -14933,7 +14933,7 @@
           <a:noFill/>
           <a:ln w="47625">
             <a:solidFill>
-              <a:srgbClr val="1F3A5F"/>
+              <a:srgbClr val="01499B"/>
             </a:solidFill>
             <a:prstDash val="solid"/>
           </a:ln>
@@ -14969,7 +14969,7 @@
             <a:r>
               <a:rPr lang="en-US" sz="1200" b="1" dirty="0">
                 <a:solidFill>
-                  <a:srgbClr val="1F3A5F"/>
+                  <a:srgbClr val="01499B"/>
                 </a:solidFill>
                 <a:latin typeface="Arial" pitchFamily="34" charset="0"/>
                 <a:ea typeface="Arial" pitchFamily="34" charset="-122"/>
@@ -15067,7 +15067,7 @@
           <a:noFill/>
           <a:ln w="47625">
             <a:solidFill>
-              <a:srgbClr val="1F3A5F"/>
+              <a:srgbClr val="01499B"/>
             </a:solidFill>
             <a:prstDash val="solid"/>
           </a:ln>
@@ -15103,7 +15103,7 @@
             <a:r>
               <a:rPr lang="en-US" sz="1200" b="1" dirty="0">
                 <a:solidFill>
-                  <a:srgbClr val="1F3A5F"/>
+                  <a:srgbClr val="01499B"/>
                 </a:solidFill>
                 <a:latin typeface="Arial" pitchFamily="34" charset="0"/>
                 <a:ea typeface="Arial" pitchFamily="34" charset="-122"/>
@@ -15201,7 +15201,7 @@
             <a:avLst/>
           </a:prstGeom>
           <a:solidFill>
-            <a:srgbClr val="1F3A5F"/>
+            <a:srgbClr val="01499B"/>
           </a:solidFill>
           <a:ln/>
         </p:spPr>
@@ -15387,7 +15387,7 @@
             <a:r>
               <a:rPr lang="en-US" sz="1000" dirty="0">
                 <a:solidFill>
-                  <a:srgbClr val="86EFAC"/>
+                  <a:srgbClr val="FBB98C"/>
                 </a:solidFill>
                 <a:latin typeface="Courier New" pitchFamily="34" charset="0"/>
                 <a:ea typeface="Courier New" pitchFamily="34" charset="-122"/>
@@ -15519,7 +15519,7 @@
             <a:r>
               <a:rPr lang="en-US" sz="1000" dirty="0">
                 <a:solidFill>
-                  <a:srgbClr val="86EFAC"/>
+                  <a:srgbClr val="FBB98C"/>
                 </a:solidFill>
                 <a:latin typeface="Courier New" pitchFamily="34" charset="0"/>
                 <a:ea typeface="Courier New" pitchFamily="34" charset="-122"/>
@@ -15651,7 +15651,7 @@
             <a:r>
               <a:rPr lang="en-US" sz="1000" dirty="0">
                 <a:solidFill>
-                  <a:srgbClr val="86EFAC"/>
+                  <a:srgbClr val="FBB98C"/>
                 </a:solidFill>
                 <a:latin typeface="Courier New" pitchFamily="34" charset="0"/>
                 <a:ea typeface="Courier New" pitchFamily="34" charset="-122"/>
@@ -15752,7 +15752,7 @@
           <a:noFill/>
           <a:ln w="47625">
             <a:solidFill>
-              <a:srgbClr val="059669"/>
+              <a:srgbClr val="F36F21"/>
             </a:solidFill>
             <a:prstDash val="solid"/>
           </a:ln>
@@ -15788,7 +15788,7 @@
             <a:r>
               <a:rPr lang="en-US" sz="1200" b="1" dirty="0">
                 <a:solidFill>
-                  <a:srgbClr val="059669"/>
+                  <a:srgbClr val="F36F21"/>
                 </a:solidFill>
                 <a:latin typeface="Arial" pitchFamily="34" charset="0"/>
                 <a:ea typeface="Arial" pitchFamily="34" charset="-122"/>
@@ -15886,7 +15886,7 @@
           <a:noFill/>
           <a:ln w="47625">
             <a:solidFill>
-              <a:srgbClr val="1F3A5F"/>
+              <a:srgbClr val="01499B"/>
             </a:solidFill>
             <a:prstDash val="solid"/>
           </a:ln>
@@ -15922,7 +15922,7 @@
             <a:r>
               <a:rPr lang="en-US" sz="1200" b="1" dirty="0">
                 <a:solidFill>
-                  <a:srgbClr val="1F3A5F"/>
+                  <a:srgbClr val="01499B"/>
                 </a:solidFill>
                 <a:latin typeface="Arial" pitchFamily="34" charset="0"/>
                 <a:ea typeface="Arial" pitchFamily="34" charset="-122"/>
@@ -16020,7 +16020,7 @@
           <a:noFill/>
           <a:ln w="47625">
             <a:solidFill>
-              <a:srgbClr val="1F3A5F"/>
+              <a:srgbClr val="01499B"/>
             </a:solidFill>
             <a:prstDash val="solid"/>
           </a:ln>
@@ -16056,7 +16056,7 @@
             <a:r>
               <a:rPr lang="en-US" sz="1200" b="1" dirty="0">
                 <a:solidFill>
-                  <a:srgbClr val="1F3A5F"/>
+                  <a:srgbClr val="01499B"/>
                 </a:solidFill>
                 <a:latin typeface="Arial" pitchFamily="34" charset="0"/>
                 <a:ea typeface="Arial" pitchFamily="34" charset="-122"/>

</xml_diff>